<commit_message>
Deploying to gh-pages from @ jhelvy/renderthis@b8dd81eb47fcbaaa623dec8be82c7d35f127ecf1 🚀
</commit_message>
<xml_diff>
--- a/example/slides.pptx
+++ b/example/slides.pptx
@@ -2988,7 +2988,7 @@
           </p:nvPr>
         </p:nvPicPr>
         <p:blipFill>
-          <a:blip cstate="print" r:embed="rId2"/>
+          <a:blip r:embed="rId2"/>
           <a:stretch>
             <a:fillRect/>
           </a:stretch>
@@ -3039,7 +3039,7 @@
           </p:nvPr>
         </p:nvPicPr>
         <p:blipFill>
-          <a:blip cstate="print" r:embed="rId2"/>
+          <a:blip r:embed="rId2"/>
           <a:stretch>
             <a:fillRect/>
           </a:stretch>
@@ -3090,7 +3090,7 @@
           </p:nvPr>
         </p:nvPicPr>
         <p:blipFill>
-          <a:blip cstate="print" r:embed="rId2"/>
+          <a:blip r:embed="rId2"/>
           <a:stretch>
             <a:fillRect/>
           </a:stretch>
@@ -3141,7 +3141,7 @@
           </p:nvPr>
         </p:nvPicPr>
         <p:blipFill>
-          <a:blip cstate="print" r:embed="rId2"/>
+          <a:blip r:embed="rId2"/>
           <a:stretch>
             <a:fillRect/>
           </a:stretch>
@@ -3192,7 +3192,7 @@
           </p:nvPr>
         </p:nvPicPr>
         <p:blipFill>
-          <a:blip cstate="print" r:embed="rId2"/>
+          <a:blip r:embed="rId2"/>
           <a:stretch>
             <a:fillRect/>
           </a:stretch>
@@ -3243,7 +3243,7 @@
           </p:nvPr>
         </p:nvPicPr>
         <p:blipFill>
-          <a:blip cstate="print" r:embed="rId2"/>
+          <a:blip r:embed="rId2"/>
           <a:stretch>
             <a:fillRect/>
           </a:stretch>
@@ -3294,7 +3294,7 @@
           </p:nvPr>
         </p:nvPicPr>
         <p:blipFill>
-          <a:blip cstate="print" r:embed="rId2"/>
+          <a:blip r:embed="rId2"/>
           <a:stretch>
             <a:fillRect/>
           </a:stretch>

</xml_diff>